<commit_message>
one xyz trajectory training + critic update
</commit_message>
<xml_diff>
--- a/documentation/Ahmed_Aboulenien_2143465_RL_project.pptx
+++ b/documentation/Ahmed_Aboulenien_2143465_RL_project.pptx
@@ -5,7 +5,7 @@
     <p:sldMasterId id="2147483648" r:id="rId1"/>
   </p:sldMasterIdLst>
   <p:notesMasterIdLst>
-    <p:notesMasterId r:id="rId25"/>
+    <p:notesMasterId r:id="rId26"/>
   </p:notesMasterIdLst>
   <p:sldIdLst>
     <p:sldId id="256" r:id="rId2"/>
@@ -31,6 +31,7 @@
     <p:sldId id="316" r:id="rId22"/>
     <p:sldId id="317" r:id="rId23"/>
     <p:sldId id="318" r:id="rId24"/>
+    <p:sldId id="320" r:id="rId25"/>
   </p:sldIdLst>
   <p:sldSz cx="12192000" cy="6858000"/>
   <p:notesSz cx="6858000" cy="9144000"/>
@@ -268,7 +269,7 @@
       <p15:sldGuideLst xmlns:p15="http://schemas.microsoft.com/office/powerpoint/2012/main"/>
     </p:ext>
     <p:ext uri="GoogleSlidesCustomDataVersion2">
-      <go:slidesCustomData xmlns="" xmlns:mc="http://schemas.openxmlformats.org/markup-compatibility/2006" xmlns:mv="urn:schemas-microsoft-com:mac:vml" xmlns:c="http://schemas.openxmlformats.org/drawingml/2006/chart" xmlns:dgm="http://schemas.openxmlformats.org/drawingml/2006/diagram" xmlns:o="urn:schemas-microsoft-com:office:office" xmlns:v="urn:schemas-microsoft-com:vml" xmlns:pvml="urn:schemas-microsoft-com:office:powerpoint" xmlns:com="http://schemas.openxmlformats.org/drawingml/2006/compatibility" xmlns:p14="http://schemas.microsoft.com/office/powerpoint/2010/main" xmlns:p15="http://schemas.microsoft.com/office/powerpoint/2012/main" xmlns:ahyp="http://schemas.microsoft.com/office/drawing/2018/hyperlinkcolor" xmlns:go="http://customooxmlschemas.google.com/" r:id="rId26" roundtripDataSignature="AMtx7mhe1wWgYMlsTmwPP8JtiEZSoLZ/AQ=="/>
+      <go:slidesCustomData xmlns="" xmlns:mc="http://schemas.openxmlformats.org/markup-compatibility/2006" xmlns:mv="urn:schemas-microsoft-com:mac:vml" xmlns:c="http://schemas.openxmlformats.org/drawingml/2006/chart" xmlns:dgm="http://schemas.openxmlformats.org/drawingml/2006/diagram" xmlns:o="urn:schemas-microsoft-com:office:office" xmlns:v="urn:schemas-microsoft-com:vml" xmlns:pvml="urn:schemas-microsoft-com:office:powerpoint" xmlns:com="http://schemas.openxmlformats.org/drawingml/2006/compatibility" xmlns:p14="http://schemas.microsoft.com/office/powerpoint/2010/main" xmlns:p15="http://schemas.microsoft.com/office/powerpoint/2012/main" xmlns:ahyp="http://schemas.microsoft.com/office/drawing/2018/hyperlinkcolor" xmlns:go="http://customooxmlschemas.google.com/" r:id="rId27" roundtripDataSignature="AMtx7mhe1wWgYMlsTmwPP8JtiEZSoLZ/AQ=="/>
     </p:ext>
   </p:extLst>
 </p:presentation>
@@ -5087,6 +5088,175 @@
     <p:extLst>
       <p:ext uri="{BB962C8B-B14F-4D97-AF65-F5344CB8AC3E}">
         <p14:creationId xmlns:p14="http://schemas.microsoft.com/office/powerpoint/2010/main" val="4080078715"/>
+      </p:ext>
+    </p:extLst>
+  </p:cSld>
+  <p:clrMapOvr>
+    <a:masterClrMapping/>
+  </p:clrMapOvr>
+</p:notes>
+</file>
+
+<file path=ppt/notesSlides/notesSlide24.xml><?xml version="1.0" encoding="utf-8"?>
+<p:notes xmlns:a="http://schemas.openxmlformats.org/drawingml/2006/main" xmlns:r="http://schemas.openxmlformats.org/officeDocument/2006/relationships" xmlns:p="http://schemas.openxmlformats.org/presentationml/2006/main" showMasterSp="0" showMasterPhAnim="0">
+  <p:cSld>
+    <p:spTree>
+      <p:nvGrpSpPr>
+        <p:cNvPr id="1" name="Shape 99"/>
+        <p:cNvGrpSpPr/>
+        <p:nvPr/>
+      </p:nvGrpSpPr>
+      <p:grpSpPr>
+        <a:xfrm>
+          <a:off x="0" y="0"/>
+          <a:ext cx="0" cy="0"/>
+          <a:chOff x="0" y="0"/>
+          <a:chExt cx="0" cy="0"/>
+        </a:xfrm>
+      </p:grpSpPr>
+      <p:sp>
+        <p:nvSpPr>
+          <p:cNvPr id="100" name="Google Shape;100;p2:notes"/>
+          <p:cNvSpPr>
+            <a:spLocks noGrp="1" noRot="1" noChangeAspect="1"/>
+          </p:cNvSpPr>
+          <p:nvPr>
+            <p:ph type="sldImg" idx="2"/>
+          </p:nvPr>
+        </p:nvSpPr>
+        <p:spPr>
+          <a:xfrm>
+            <a:off x="685800" y="1143000"/>
+            <a:ext cx="5486400" cy="3086100"/>
+          </a:xfrm>
+          <a:custGeom>
+            <a:avLst/>
+            <a:gdLst/>
+            <a:ahLst/>
+            <a:cxnLst/>
+            <a:rect l="l" t="t" r="r" b="b"/>
+            <a:pathLst>
+              <a:path w="120000" h="120000" extrusionOk="0">
+                <a:moveTo>
+                  <a:pt x="0" y="0"/>
+                </a:moveTo>
+                <a:lnTo>
+                  <a:pt x="120000" y="0"/>
+                </a:lnTo>
+                <a:lnTo>
+                  <a:pt x="120000" y="120000"/>
+                </a:lnTo>
+                <a:lnTo>
+                  <a:pt x="0" y="120000"/>
+                </a:lnTo>
+                <a:close/>
+              </a:path>
+            </a:pathLst>
+          </a:custGeom>
+          <a:noFill/>
+          <a:ln w="12700" cap="flat" cmpd="sng">
+            <a:solidFill>
+              <a:srgbClr val="000000"/>
+            </a:solidFill>
+            <a:prstDash val="solid"/>
+            <a:round/>
+            <a:headEnd type="none" w="sm" len="sm"/>
+            <a:tailEnd type="none" w="sm" len="sm"/>
+          </a:ln>
+        </p:spPr>
+      </p:sp>
+      <p:sp>
+        <p:nvSpPr>
+          <p:cNvPr id="101" name="Google Shape;101;p2:notes"/>
+          <p:cNvSpPr txBox="1">
+            <a:spLocks noGrp="1"/>
+          </p:cNvSpPr>
+          <p:nvPr>
+            <p:ph type="body" idx="1"/>
+          </p:nvPr>
+        </p:nvSpPr>
+        <p:spPr>
+          <a:xfrm>
+            <a:off x="685800" y="4400550"/>
+            <a:ext cx="5486400" cy="3600450"/>
+          </a:xfrm>
+          <a:prstGeom prst="rect">
+            <a:avLst/>
+          </a:prstGeom>
+          <a:noFill/>
+          <a:ln>
+            <a:noFill/>
+          </a:ln>
+        </p:spPr>
+        <p:txBody>
+          <a:bodyPr spcFirstLastPara="1" wrap="square" lIns="91425" tIns="45700" rIns="91425" bIns="45700" anchor="t" anchorCtr="0">
+            <a:noAutofit/>
+          </a:bodyPr>
+          <a:lstStyle/>
+          <a:p>
+            <a:pPr marL="0" lvl="0" indent="0" algn="l" rtl="0">
+              <a:spcBef>
+                <a:spcPts val="0"/>
+              </a:spcBef>
+              <a:spcAft>
+                <a:spcPts val="0"/>
+              </a:spcAft>
+              <a:buNone/>
+            </a:pPr>
+            <a:endParaRPr dirty="0"/>
+          </a:p>
+        </p:txBody>
+      </p:sp>
+      <p:sp>
+        <p:nvSpPr>
+          <p:cNvPr id="102" name="Google Shape;102;p2:notes"/>
+          <p:cNvSpPr txBox="1">
+            <a:spLocks noGrp="1"/>
+          </p:cNvSpPr>
+          <p:nvPr>
+            <p:ph type="sldNum" idx="12"/>
+          </p:nvPr>
+        </p:nvSpPr>
+        <p:spPr>
+          <a:xfrm>
+            <a:off x="3884613" y="8685213"/>
+            <a:ext cx="2971800" cy="458787"/>
+          </a:xfrm>
+          <a:prstGeom prst="rect">
+            <a:avLst/>
+          </a:prstGeom>
+          <a:noFill/>
+          <a:ln>
+            <a:noFill/>
+          </a:ln>
+        </p:spPr>
+        <p:txBody>
+          <a:bodyPr spcFirstLastPara="1" wrap="square" lIns="91425" tIns="45700" rIns="91425" bIns="45700" anchor="b" anchorCtr="0">
+            <a:noAutofit/>
+          </a:bodyPr>
+          <a:lstStyle/>
+          <a:p>
+            <a:pPr marL="0" lvl="0" indent="0" algn="r" rtl="0">
+              <a:spcBef>
+                <a:spcPts val="0"/>
+              </a:spcBef>
+              <a:spcAft>
+                <a:spcPts val="0"/>
+              </a:spcAft>
+              <a:buNone/>
+            </a:pPr>
+            <a:fld id="{00000000-1234-1234-1234-123412341234}" type="slidenum">
+              <a:rPr lang="it-IT"/>
+              <a:t>24</a:t>
+            </a:fld>
+            <a:endParaRPr/>
+          </a:p>
+        </p:txBody>
+      </p:sp>
+    </p:spTree>
+    <p:extLst>
+      <p:ext uri="{BB962C8B-B14F-4D97-AF65-F5344CB8AC3E}">
+        <p14:creationId xmlns:p14="http://schemas.microsoft.com/office/powerpoint/2010/main" val="618663335"/>
       </p:ext>
     </p:extLst>
   </p:cSld>
@@ -16729,7 +16899,7 @@
         </p:nvSpPr>
         <p:spPr>
           <a:xfrm>
-            <a:off x="2935525" y="5295508"/>
+            <a:off x="3108245" y="5163428"/>
             <a:ext cx="6320949" cy="758068"/>
           </a:xfrm>
           <a:prstGeom prst="rect">
@@ -16788,6 +16958,24 @@
               <a:rPr lang="en-US" sz="3200" dirty="0" smtClean="0"/>
               <a:t>Part of thesis</a:t>
             </a:r>
+          </a:p>
+          <a:p>
+            <a:pPr marL="0" lvl="0" indent="0" algn="ctr" rtl="0">
+              <a:lnSpc>
+                <a:spcPct val="90000"/>
+              </a:lnSpc>
+              <a:spcBef>
+                <a:spcPts val="0"/>
+              </a:spcBef>
+              <a:spcAft>
+                <a:spcPts val="0"/>
+              </a:spcAft>
+              <a:buClr>
+                <a:schemeClr val="lt1"/>
+              </a:buClr>
+              <a:buSzPts val="3200"/>
+              <a:buNone/>
+            </a:pPr>
             <a:endParaRPr sz="3200" dirty="0"/>
           </a:p>
         </p:txBody>
@@ -20711,7 +20899,7 @@
           <a:p>
             <a:pPr algn="ctr"/>
             <a:r>
-              <a:rPr sz="850" smtClean="0">
+              <a:rPr sz="850" dirty="0" smtClean="0">
                 <a:solidFill>
                   <a:srgbClr val="000000"/>
                 </a:solidFill>
@@ -20720,7 +20908,7 @@
               <a:t>obs</a:t>
             </a:r>
             <a:r>
-              <a:rPr lang="en-US" sz="850" smtClean="0">
+              <a:rPr lang="en-US" sz="850" dirty="0" smtClean="0">
                 <a:solidFill>
                   <a:srgbClr val="000000"/>
                 </a:solidFill>
@@ -20729,7 +20917,7 @@
               <a:t>ervation</a:t>
             </a:r>
             <a:r>
-              <a:rPr sz="850" smtClean="0">
+              <a:rPr sz="850" dirty="0" smtClean="0">
                 <a:solidFill>
                   <a:srgbClr val="000000"/>
                 </a:solidFill>
@@ -25579,6 +25767,187 @@
     <p:extLst>
       <p:ext uri="{BB962C8B-B14F-4D97-AF65-F5344CB8AC3E}">
         <p14:creationId xmlns:p14="http://schemas.microsoft.com/office/powerpoint/2010/main" val="1170021896"/>
+      </p:ext>
+    </p:extLst>
+  </p:cSld>
+  <p:clrMapOvr>
+    <a:masterClrMapping/>
+  </p:clrMapOvr>
+  <p:timing>
+    <p:tnLst>
+      <p:par>
+        <p:cTn id="1" dur="indefinite" restart="never" nodeType="tmRoot"/>
+      </p:par>
+    </p:tnLst>
+  </p:timing>
+</p:sld>
+</file>
+
+<file path=ppt/slides/slide24.xml><?xml version="1.0" encoding="utf-8"?>
+<p:sld xmlns:a="http://schemas.openxmlformats.org/drawingml/2006/main" xmlns:r="http://schemas.openxmlformats.org/officeDocument/2006/relationships" xmlns:p="http://schemas.openxmlformats.org/presentationml/2006/main">
+  <p:cSld>
+    <p:spTree>
+      <p:nvGrpSpPr>
+        <p:cNvPr id="1" name="Shape 103"/>
+        <p:cNvGrpSpPr/>
+        <p:nvPr/>
+      </p:nvGrpSpPr>
+      <p:grpSpPr>
+        <a:xfrm>
+          <a:off x="0" y="0"/>
+          <a:ext cx="0" cy="0"/>
+          <a:chOff x="0" y="0"/>
+          <a:chExt cx="0" cy="0"/>
+        </a:xfrm>
+      </p:grpSpPr>
+      <p:sp>
+        <p:nvSpPr>
+          <p:cNvPr id="104" name="Google Shape;104;p2"/>
+          <p:cNvSpPr txBox="1">
+            <a:spLocks noGrp="1"/>
+          </p:cNvSpPr>
+          <p:nvPr>
+            <p:ph type="title"/>
+          </p:nvPr>
+        </p:nvSpPr>
+        <p:spPr>
+          <a:xfrm>
+            <a:off x="456000" y="1142356"/>
+            <a:ext cx="11736000" cy="1188000"/>
+          </a:xfrm>
+          <a:prstGeom prst="rect">
+            <a:avLst/>
+          </a:prstGeom>
+          <a:noFill/>
+          <a:ln>
+            <a:noFill/>
+          </a:ln>
+        </p:spPr>
+        <p:txBody>
+          <a:bodyPr spcFirstLastPara="1" wrap="square" lIns="91425" tIns="45700" rIns="91425" bIns="45700" anchor="ctr" anchorCtr="0">
+            <a:normAutofit/>
+          </a:bodyPr>
+          <a:lstStyle/>
+          <a:p>
+            <a:pPr marL="0" lvl="0" indent="0" algn="l" rtl="0">
+              <a:lnSpc>
+                <a:spcPct val="90000"/>
+              </a:lnSpc>
+              <a:spcBef>
+                <a:spcPts val="0"/>
+              </a:spcBef>
+              <a:spcAft>
+                <a:spcPts val="0"/>
+              </a:spcAft>
+              <a:buClr>
+                <a:schemeClr val="dk1"/>
+              </a:buClr>
+              <a:buSzPts val="3600"/>
+              <a:buFont typeface="Arial"/>
+              <a:buNone/>
+            </a:pPr>
+            <a:r>
+              <a:rPr lang="en-US" dirty="0" smtClean="0"/>
+              <a:t>Residual MARL: Code</a:t>
+            </a:r>
+            <a:endParaRPr dirty="0"/>
+          </a:p>
+        </p:txBody>
+      </p:sp>
+      <p:sp>
+        <p:nvSpPr>
+          <p:cNvPr id="105" name="Google Shape;105;p2"/>
+          <p:cNvSpPr txBox="1">
+            <a:spLocks noGrp="1"/>
+          </p:cNvSpPr>
+          <p:nvPr>
+            <p:ph type="body" idx="4294967295"/>
+          </p:nvPr>
+        </p:nvSpPr>
+        <p:spPr>
+          <a:xfrm>
+            <a:off x="455998" y="2178768"/>
+            <a:ext cx="11489567" cy="4520796"/>
+          </a:xfrm>
+          <a:prstGeom prst="rect">
+            <a:avLst/>
+          </a:prstGeom>
+          <a:noFill/>
+          <a:ln>
+            <a:noFill/>
+          </a:ln>
+        </p:spPr>
+        <p:txBody>
+          <a:bodyPr spcFirstLastPara="1" wrap="square" lIns="91425" tIns="45700" rIns="91425" bIns="45700" anchor="t" anchorCtr="0">
+            <a:normAutofit/>
+          </a:bodyPr>
+          <a:lstStyle/>
+          <a:p>
+            <a:pPr indent="-457200">
+              <a:buSzPts val="3200"/>
+            </a:pPr>
+            <a:r>
+              <a:rPr lang="en-US" dirty="0" smtClean="0">
+                <a:hlinkClick r:id="rId3"/>
+              </a:rPr>
+              <a:t>Github</a:t>
+            </a:r>
+            <a:endParaRPr lang="en-US" dirty="0" smtClean="0"/>
+          </a:p>
+          <a:p>
+            <a:pPr indent="-457200">
+              <a:buSzPts val="3200"/>
+            </a:pPr>
+            <a:r>
+              <a:rPr lang="en-US" dirty="0" smtClean="0">
+                <a:hlinkClick r:id="rId4"/>
+              </a:rPr>
+              <a:t>MAPPO</a:t>
+            </a:r>
+            <a:endParaRPr lang="en-US" dirty="0" smtClean="0"/>
+          </a:p>
+          <a:p>
+            <a:pPr indent="-457200">
+              <a:buSzPts val="3200"/>
+            </a:pPr>
+            <a:r>
+              <a:rPr lang="en-US" dirty="0" smtClean="0">
+                <a:hlinkClick r:id="rId5"/>
+              </a:rPr>
+              <a:t>MARL Environment</a:t>
+            </a:r>
+            <a:endParaRPr lang="en-US" dirty="0" smtClean="0"/>
+          </a:p>
+          <a:p>
+            <a:pPr indent="-457200">
+              <a:buSzPts val="3200"/>
+            </a:pPr>
+            <a:r>
+              <a:rPr lang="en-US" dirty="0" smtClean="0">
+                <a:hlinkClick r:id="rId6"/>
+              </a:rPr>
+              <a:t>Trajectory test</a:t>
+            </a:r>
+            <a:endParaRPr lang="en-US" dirty="0"/>
+          </a:p>
+          <a:p>
+            <a:pPr indent="-457200">
+              <a:buSzPts val="3200"/>
+            </a:pPr>
+            <a:endParaRPr lang="en-US" dirty="0"/>
+          </a:p>
+          <a:p>
+            <a:pPr indent="-457200">
+              <a:buSzPts val="3200"/>
+            </a:pPr>
+            <a:endParaRPr lang="en-US" dirty="0"/>
+          </a:p>
+        </p:txBody>
+      </p:sp>
+    </p:spTree>
+    <p:extLst>
+      <p:ext uri="{BB962C8B-B14F-4D97-AF65-F5344CB8AC3E}">
+        <p14:creationId xmlns:p14="http://schemas.microsoft.com/office/powerpoint/2010/main" val="3164996519"/>
       </p:ext>
     </p:extLst>
   </p:cSld>

</xml_diff>